<commit_message>
aggiunto template e diagramma immagine
</commit_message>
<xml_diff>
--- a/TemplateLaurea_L8_Ingegneria_Informatica.pptx
+++ b/TemplateLaurea_L8_Ingegneria_Informatica.pptx
@@ -132,6 +132,99 @@
 
 <file path=ppt/changesInfos/changesInfo1.xml><?xml version="1.0" encoding="utf-8"?>
 <pc:chgInfo xmlns:a="http://schemas.openxmlformats.org/drawingml/2006/main" xmlns:r="http://schemas.openxmlformats.org/officeDocument/2006/relationships" xmlns:ac="http://schemas.microsoft.com/office/drawing/2013/main/command" xmlns:pc="http://schemas.microsoft.com/office/powerpoint/2013/main/command">
+  <pc:docChgLst>
+    <pc:chgData name="Orazio Tomarchio" userId="127280df-7b21-40f7-a364-a9ecddca11f6" providerId="ADAL" clId="{76C659F5-8ABD-4A95-93CD-55E82B072CA7}"/>
+    <pc:docChg chg="custSel modSld modMainMaster">
+      <pc:chgData name="Orazio Tomarchio" userId="127280df-7b21-40f7-a364-a9ecddca11f6" providerId="ADAL" clId="{76C659F5-8ABD-4A95-93CD-55E82B072CA7}" dt="2023-02-11T08:50:49.850" v="45" actId="6549"/>
+      <pc:docMkLst>
+        <pc:docMk/>
+      </pc:docMkLst>
+      <pc:sldChg chg="modSp mod modNotesTx">
+        <pc:chgData name="Orazio Tomarchio" userId="127280df-7b21-40f7-a364-a9ecddca11f6" providerId="ADAL" clId="{76C659F5-8ABD-4A95-93CD-55E82B072CA7}" dt="2023-02-11T08:50:49.850" v="45" actId="6549"/>
+        <pc:sldMkLst>
+          <pc:docMk/>
+          <pc:sldMk cId="2004898496" sldId="256"/>
+        </pc:sldMkLst>
+        <pc:spChg chg="mod">
+          <ac:chgData name="Orazio Tomarchio" userId="127280df-7b21-40f7-a364-a9ecddca11f6" providerId="ADAL" clId="{76C659F5-8ABD-4A95-93CD-55E82B072CA7}" dt="2023-02-11T08:40:38.755" v="20" actId="20577"/>
+          <ac:spMkLst>
+            <pc:docMk/>
+            <pc:sldMk cId="2004898496" sldId="256"/>
+            <ac:spMk id="8" creationId="{93D06744-791D-6AFB-6E80-8ADD7B53F11C}"/>
+          </ac:spMkLst>
+        </pc:spChg>
+        <pc:spChg chg="mod">
+          <ac:chgData name="Orazio Tomarchio" userId="127280df-7b21-40f7-a364-a9ecddca11f6" providerId="ADAL" clId="{76C659F5-8ABD-4A95-93CD-55E82B072CA7}" dt="2023-02-11T08:50:49.850" v="45" actId="6549"/>
+          <ac:spMkLst>
+            <pc:docMk/>
+            <pc:sldMk cId="2004898496" sldId="256"/>
+            <ac:spMk id="14" creationId="{265AD214-7CE6-ADC3-95E1-F7693CCE6A69}"/>
+          </ac:spMkLst>
+        </pc:spChg>
+      </pc:sldChg>
+      <pc:sldMasterChg chg="modSp mod">
+        <pc:chgData name="Orazio Tomarchio" userId="127280df-7b21-40f7-a364-a9ecddca11f6" providerId="ADAL" clId="{76C659F5-8ABD-4A95-93CD-55E82B072CA7}" dt="2023-02-11T08:47:57.881" v="40" actId="1036"/>
+        <pc:sldMasterMkLst>
+          <pc:docMk/>
+          <pc:sldMasterMk cId="617994796" sldId="2147483648"/>
+        </pc:sldMasterMkLst>
+        <pc:spChg chg="mod">
+          <ac:chgData name="Orazio Tomarchio" userId="127280df-7b21-40f7-a364-a9ecddca11f6" providerId="ADAL" clId="{76C659F5-8ABD-4A95-93CD-55E82B072CA7}" dt="2023-02-11T08:47:57.881" v="40" actId="1036"/>
+          <ac:spMkLst>
+            <pc:docMk/>
+            <pc:sldMasterMk cId="617994796" sldId="2147483648"/>
+            <ac:spMk id="11" creationId="{FD0938AB-A189-499C-8BD1-DE81DA518432}"/>
+          </ac:spMkLst>
+        </pc:spChg>
+      </pc:sldMasterChg>
+      <pc:sldMasterChg chg="addSp delSp modSp mod">
+        <pc:chgData name="Orazio Tomarchio" userId="127280df-7b21-40f7-a364-a9ecddca11f6" providerId="ADAL" clId="{76C659F5-8ABD-4A95-93CD-55E82B072CA7}" dt="2023-02-11T08:50:18.576" v="42"/>
+        <pc:sldMasterMkLst>
+          <pc:docMk/>
+          <pc:sldMasterMk cId="2494966399" sldId="2147483659"/>
+        </pc:sldMasterMkLst>
+        <pc:spChg chg="del">
+          <ac:chgData name="Orazio Tomarchio" userId="127280df-7b21-40f7-a364-a9ecddca11f6" providerId="ADAL" clId="{76C659F5-8ABD-4A95-93CD-55E82B072CA7}" dt="2023-02-11T08:50:18.037" v="41" actId="478"/>
+          <ac:spMkLst>
+            <pc:docMk/>
+            <pc:sldMasterMk cId="2494966399" sldId="2147483659"/>
+            <ac:spMk id="4" creationId="{5DAD65C5-A95C-8A0F-7003-D0363FD133AA}"/>
+          </ac:spMkLst>
+        </pc:spChg>
+        <pc:spChg chg="add mod">
+          <ac:chgData name="Orazio Tomarchio" userId="127280df-7b21-40f7-a364-a9ecddca11f6" providerId="ADAL" clId="{76C659F5-8ABD-4A95-93CD-55E82B072CA7}" dt="2023-02-11T08:50:18.576" v="42"/>
+          <ac:spMkLst>
+            <pc:docMk/>
+            <pc:sldMasterMk cId="2494966399" sldId="2147483659"/>
+            <ac:spMk id="6" creationId="{F4DE8FFE-8AB4-F595-84AB-3DAAAA75817F}"/>
+          </ac:spMkLst>
+        </pc:spChg>
+      </pc:sldMasterChg>
+      <pc:sldMasterChg chg="addSp delSp modSp mod">
+        <pc:chgData name="Orazio Tomarchio" userId="127280df-7b21-40f7-a364-a9ecddca11f6" providerId="ADAL" clId="{76C659F5-8ABD-4A95-93CD-55E82B072CA7}" dt="2023-02-11T08:50:28.246" v="44"/>
+        <pc:sldMasterMkLst>
+          <pc:docMk/>
+          <pc:sldMasterMk cId="3386500721" sldId="2147483670"/>
+        </pc:sldMasterMkLst>
+        <pc:spChg chg="del">
+          <ac:chgData name="Orazio Tomarchio" userId="127280df-7b21-40f7-a364-a9ecddca11f6" providerId="ADAL" clId="{76C659F5-8ABD-4A95-93CD-55E82B072CA7}" dt="2023-02-11T08:50:27.614" v="43" actId="478"/>
+          <ac:spMkLst>
+            <pc:docMk/>
+            <pc:sldMasterMk cId="3386500721" sldId="2147483670"/>
+            <ac:spMk id="4" creationId="{AF07C65F-4C6D-E5C8-1A0F-F68ACE858387}"/>
+          </ac:spMkLst>
+        </pc:spChg>
+        <pc:spChg chg="add mod">
+          <ac:chgData name="Orazio Tomarchio" userId="127280df-7b21-40f7-a364-a9ecddca11f6" providerId="ADAL" clId="{76C659F5-8ABD-4A95-93CD-55E82B072CA7}" dt="2023-02-11T08:50:28.246" v="44"/>
+          <ac:spMkLst>
+            <pc:docMk/>
+            <pc:sldMasterMk cId="3386500721" sldId="2147483670"/>
+            <ac:spMk id="5" creationId="{4CF82A50-AB3A-78BA-7CB5-168A181E62FF}"/>
+          </ac:spMkLst>
+        </pc:spChg>
+      </pc:sldMasterChg>
+    </pc:docChg>
+  </pc:docChgLst>
   <pc:docChgLst>
     <pc:chgData name="Orazio Tomarchio" userId="127280df-7b21-40f7-a364-a9ecddca11f6" providerId="ADAL" clId="{AF467704-1BEC-493F-B910-243A3A72653D}"/>
     <pc:docChg chg="undo custSel modSld modMainMaster">
@@ -320,99 +413,6 @@
       </pc:sldMasterChg>
     </pc:docChg>
   </pc:docChgLst>
-  <pc:docChgLst>
-    <pc:chgData name="Orazio Tomarchio" userId="127280df-7b21-40f7-a364-a9ecddca11f6" providerId="ADAL" clId="{76C659F5-8ABD-4A95-93CD-55E82B072CA7}"/>
-    <pc:docChg chg="custSel modSld modMainMaster">
-      <pc:chgData name="Orazio Tomarchio" userId="127280df-7b21-40f7-a364-a9ecddca11f6" providerId="ADAL" clId="{76C659F5-8ABD-4A95-93CD-55E82B072CA7}" dt="2023-02-11T08:50:49.850" v="45" actId="6549"/>
-      <pc:docMkLst>
-        <pc:docMk/>
-      </pc:docMkLst>
-      <pc:sldChg chg="modSp mod modNotesTx">
-        <pc:chgData name="Orazio Tomarchio" userId="127280df-7b21-40f7-a364-a9ecddca11f6" providerId="ADAL" clId="{76C659F5-8ABD-4A95-93CD-55E82B072CA7}" dt="2023-02-11T08:50:49.850" v="45" actId="6549"/>
-        <pc:sldMkLst>
-          <pc:docMk/>
-          <pc:sldMk cId="2004898496" sldId="256"/>
-        </pc:sldMkLst>
-        <pc:spChg chg="mod">
-          <ac:chgData name="Orazio Tomarchio" userId="127280df-7b21-40f7-a364-a9ecddca11f6" providerId="ADAL" clId="{76C659F5-8ABD-4A95-93CD-55E82B072CA7}" dt="2023-02-11T08:40:38.755" v="20" actId="20577"/>
-          <ac:spMkLst>
-            <pc:docMk/>
-            <pc:sldMk cId="2004898496" sldId="256"/>
-            <ac:spMk id="8" creationId="{93D06744-791D-6AFB-6E80-8ADD7B53F11C}"/>
-          </ac:spMkLst>
-        </pc:spChg>
-        <pc:spChg chg="mod">
-          <ac:chgData name="Orazio Tomarchio" userId="127280df-7b21-40f7-a364-a9ecddca11f6" providerId="ADAL" clId="{76C659F5-8ABD-4A95-93CD-55E82B072CA7}" dt="2023-02-11T08:50:49.850" v="45" actId="6549"/>
-          <ac:spMkLst>
-            <pc:docMk/>
-            <pc:sldMk cId="2004898496" sldId="256"/>
-            <ac:spMk id="14" creationId="{265AD214-7CE6-ADC3-95E1-F7693CCE6A69}"/>
-          </ac:spMkLst>
-        </pc:spChg>
-      </pc:sldChg>
-      <pc:sldMasterChg chg="modSp mod">
-        <pc:chgData name="Orazio Tomarchio" userId="127280df-7b21-40f7-a364-a9ecddca11f6" providerId="ADAL" clId="{76C659F5-8ABD-4A95-93CD-55E82B072CA7}" dt="2023-02-11T08:47:57.881" v="40" actId="1036"/>
-        <pc:sldMasterMkLst>
-          <pc:docMk/>
-          <pc:sldMasterMk cId="617994796" sldId="2147483648"/>
-        </pc:sldMasterMkLst>
-        <pc:spChg chg="mod">
-          <ac:chgData name="Orazio Tomarchio" userId="127280df-7b21-40f7-a364-a9ecddca11f6" providerId="ADAL" clId="{76C659F5-8ABD-4A95-93CD-55E82B072CA7}" dt="2023-02-11T08:47:57.881" v="40" actId="1036"/>
-          <ac:spMkLst>
-            <pc:docMk/>
-            <pc:sldMasterMk cId="617994796" sldId="2147483648"/>
-            <ac:spMk id="11" creationId="{FD0938AB-A189-499C-8BD1-DE81DA518432}"/>
-          </ac:spMkLst>
-        </pc:spChg>
-      </pc:sldMasterChg>
-      <pc:sldMasterChg chg="addSp delSp modSp mod">
-        <pc:chgData name="Orazio Tomarchio" userId="127280df-7b21-40f7-a364-a9ecddca11f6" providerId="ADAL" clId="{76C659F5-8ABD-4A95-93CD-55E82B072CA7}" dt="2023-02-11T08:50:18.576" v="42"/>
-        <pc:sldMasterMkLst>
-          <pc:docMk/>
-          <pc:sldMasterMk cId="2494966399" sldId="2147483659"/>
-        </pc:sldMasterMkLst>
-        <pc:spChg chg="del">
-          <ac:chgData name="Orazio Tomarchio" userId="127280df-7b21-40f7-a364-a9ecddca11f6" providerId="ADAL" clId="{76C659F5-8ABD-4A95-93CD-55E82B072CA7}" dt="2023-02-11T08:50:18.037" v="41" actId="478"/>
-          <ac:spMkLst>
-            <pc:docMk/>
-            <pc:sldMasterMk cId="2494966399" sldId="2147483659"/>
-            <ac:spMk id="4" creationId="{5DAD65C5-A95C-8A0F-7003-D0363FD133AA}"/>
-          </ac:spMkLst>
-        </pc:spChg>
-        <pc:spChg chg="add mod">
-          <ac:chgData name="Orazio Tomarchio" userId="127280df-7b21-40f7-a364-a9ecddca11f6" providerId="ADAL" clId="{76C659F5-8ABD-4A95-93CD-55E82B072CA7}" dt="2023-02-11T08:50:18.576" v="42"/>
-          <ac:spMkLst>
-            <pc:docMk/>
-            <pc:sldMasterMk cId="2494966399" sldId="2147483659"/>
-            <ac:spMk id="6" creationId="{F4DE8FFE-8AB4-F595-84AB-3DAAAA75817F}"/>
-          </ac:spMkLst>
-        </pc:spChg>
-      </pc:sldMasterChg>
-      <pc:sldMasterChg chg="addSp delSp modSp mod">
-        <pc:chgData name="Orazio Tomarchio" userId="127280df-7b21-40f7-a364-a9ecddca11f6" providerId="ADAL" clId="{76C659F5-8ABD-4A95-93CD-55E82B072CA7}" dt="2023-02-11T08:50:28.246" v="44"/>
-        <pc:sldMasterMkLst>
-          <pc:docMk/>
-          <pc:sldMasterMk cId="3386500721" sldId="2147483670"/>
-        </pc:sldMasterMkLst>
-        <pc:spChg chg="del">
-          <ac:chgData name="Orazio Tomarchio" userId="127280df-7b21-40f7-a364-a9ecddca11f6" providerId="ADAL" clId="{76C659F5-8ABD-4A95-93CD-55E82B072CA7}" dt="2023-02-11T08:50:27.614" v="43" actId="478"/>
-          <ac:spMkLst>
-            <pc:docMk/>
-            <pc:sldMasterMk cId="3386500721" sldId="2147483670"/>
-            <ac:spMk id="4" creationId="{AF07C65F-4C6D-E5C8-1A0F-F68ACE858387}"/>
-          </ac:spMkLst>
-        </pc:spChg>
-        <pc:spChg chg="add mod">
-          <ac:chgData name="Orazio Tomarchio" userId="127280df-7b21-40f7-a364-a9ecddca11f6" providerId="ADAL" clId="{76C659F5-8ABD-4A95-93CD-55E82B072CA7}" dt="2023-02-11T08:50:28.246" v="44"/>
-          <ac:spMkLst>
-            <pc:docMk/>
-            <pc:sldMasterMk cId="3386500721" sldId="2147483670"/>
-            <ac:spMk id="5" creationId="{4CF82A50-AB3A-78BA-7CB5-168A181E62FF}"/>
-          </ac:spMkLst>
-        </pc:spChg>
-      </pc:sldMasterChg>
-    </pc:docChg>
-  </pc:docChgLst>
 </pc:chgInfo>
 </file>
 
@@ -498,7 +498,7 @@
           <a:p>
             <a:fld id="{D9A03290-C39D-45B6-9EA8-560DDA0656D7}" type="datetimeFigureOut">
               <a:rPr lang="it-IT" smtClean="0"/>
-              <a:t>12/02/2023</a:t>
+              <a:t>09/07/26</a:t>
             </a:fld>
             <a:endParaRPr lang="it-IT"/>
           </a:p>
@@ -10055,13 +10055,21 @@
           <a:lstStyle/>
           <a:p>
             <a:r>
-              <a:rPr lang="it-IT" dirty="0">
-                <a:solidFill>
-                  <a:schemeClr val="tx1"/>
-                </a:solidFill>
-              </a:rPr>
-              <a:t>Titolo della tesi</a:t>
-            </a:r>
+              <a:rPr lang="it-IT" sz="2800" dirty="0"/>
+              <a:t>Riconoscimento automatico di risse in sequenze video</a:t>
+            </a:r>
+            <a:br>
+              <a:rPr lang="it-IT" sz="2800" dirty="0"/>
+            </a:br>
+            <a:r>
+              <a:rPr lang="it-IT" sz="2800" dirty="0"/>
+              <a:t>mediante tecniche di computer vision e deep learning</a:t>
+            </a:r>
+            <a:endParaRPr lang="it-IT" sz="2800" dirty="0">
+              <a:solidFill>
+                <a:schemeClr val="tx1"/>
+              </a:solidFill>
+            </a:endParaRPr>
           </a:p>
         </p:txBody>
       </p:sp>
@@ -10088,7 +10096,7 @@
           <a:p>
             <a:r>
               <a:rPr lang="it-IT" b="1" dirty="0"/>
-              <a:t>Nome e Cognome del candidato</a:t>
+              <a:t>William Villari</a:t>
             </a:r>
           </a:p>
         </p:txBody>
@@ -10112,7 +10120,7 @@
         <p:spPr/>
         <p:txBody>
           <a:bodyPr>
-            <a:normAutofit/>
+            <a:normAutofit fontScale="25000" lnSpcReduction="20000"/>
           </a:bodyPr>
           <a:lstStyle/>
           <a:p>
@@ -10120,32 +10128,43 @@
           </a:p>
           <a:p>
             <a:r>
-              <a:rPr lang="it-IT" sz="1800" dirty="0"/>
-              <a:t>Relatore: prof. </a:t>
-            </a:r>
-            <a:r>
-              <a:rPr lang="it-IT" sz="1800" b="1" dirty="0" err="1"/>
-              <a:t>Xxxxx</a:t>
-            </a:r>
-            <a:r>
-              <a:rPr lang="it-IT" sz="1800" b="1" dirty="0"/>
+              <a:rPr lang="it-IT" sz="7200" dirty="0"/>
+              <a:t>Relatrice: Prof.ssa Roberta Avanzato</a:t>
+            </a:r>
+          </a:p>
+          <a:p>
+            <a:r>
+              <a:rPr lang="it-IT" sz="6400" dirty="0"/>
+              <a:t>Correlatore: Prof. Francesco </a:t>
+            </a:r>
+            <a:r>
+              <a:rPr lang="it-IT" sz="6400" dirty="0" err="1"/>
+              <a:t>Beritelli</a:t>
+            </a:r>
+            <a:r>
+              <a:rPr lang="it-IT" sz="6400" dirty="0"/>
               <a:t> </a:t>
             </a:r>
-            <a:r>
-              <a:rPr lang="it-IT" sz="1800" b="1" dirty="0" err="1"/>
-              <a:t>Yyyyy</a:t>
-            </a:r>
-            <a:endParaRPr lang="it-IT" dirty="0"/>
+          </a:p>
+          <a:p>
+            <a:r>
+              <a:rPr lang="it-IT" sz="6400" dirty="0"/>
+              <a:t>Correlatrice: Ing. Ludovica </a:t>
+            </a:r>
+            <a:r>
+              <a:rPr lang="it-IT" sz="6400" dirty="0" err="1"/>
+              <a:t>Beritelli</a:t>
+            </a:r>
+            <a:endParaRPr lang="it-IT" sz="6400" dirty="0"/>
           </a:p>
           <a:p>
             <a:endParaRPr lang="it-IT" sz="1600" dirty="0"/>
           </a:p>
           <a:p>
             <a:r>
-              <a:rPr lang="it-IT" sz="1600" dirty="0"/>
-              <a:t>data della seduta di laurea</a:t>
-            </a:r>
-            <a:endParaRPr lang="it-IT" dirty="0"/>
+              <a:rPr lang="it-IT" sz="6400" dirty="0"/>
+              <a:t>27/07/2026</a:t>
+            </a:r>
           </a:p>
         </p:txBody>
       </p:sp>
@@ -10223,9 +10242,16 @@
             <p:ph idx="1"/>
           </p:nvPr>
         </p:nvSpPr>
-        <p:spPr/>
+        <p:spPr>
+          <a:xfrm>
+            <a:off x="838201" y="1825625"/>
+            <a:ext cx="5257800" cy="4017614"/>
+          </a:xfrm>
+        </p:spPr>
         <p:txBody>
-          <a:bodyPr/>
+          <a:bodyPr>
+            <a:normAutofit fontScale="92500" lnSpcReduction="10000"/>
+          </a:bodyPr>
           <a:lstStyle/>
           <a:p>
             <a:pPr>
@@ -10234,48 +10260,28 @@
               </a:lnSpc>
             </a:pPr>
             <a:r>
-              <a:rPr lang="it-IT" dirty="0"/>
-              <a:t>Descrivere sinteticamente:</a:t>
-            </a:r>
-          </a:p>
-          <a:p>
-            <a:pPr lvl="1">
+              <a:rPr lang="it-IT" sz="2400" b="1" dirty="0"/>
+              <a:t>Contesto</a:t>
+            </a:r>
+            <a:r>
+              <a:rPr lang="it-IT" sz="2400" dirty="0"/>
+              <a:t>: Videosorveglianza </a:t>
+            </a:r>
+            <a:r>
+              <a:rPr lang="it-IT" sz="2400" i="1" dirty="0"/>
+              <a:t>Smart City </a:t>
+            </a:r>
+            <a:r>
+              <a:rPr lang="it-IT" sz="2400" dirty="0"/>
+              <a:t>dovuto ai limiti della supervisione umana</a:t>
+            </a:r>
+          </a:p>
+          <a:p>
+            <a:pPr marL="0" indent="0">
               <a:lnSpc>
                 <a:spcPct val="100000"/>
               </a:lnSpc>
-            </a:pPr>
-            <a:r>
-              <a:rPr lang="it-IT" dirty="0"/>
-              <a:t>Scenario/contesto del lavoro svolto</a:t>
-            </a:r>
-          </a:p>
-          <a:p>
-            <a:pPr lvl="1">
-              <a:lnSpc>
-                <a:spcPct val="100000"/>
-              </a:lnSpc>
-            </a:pPr>
-            <a:r>
-              <a:rPr lang="it-IT" dirty="0"/>
-              <a:t>obiettivi principali della tesi</a:t>
-            </a:r>
-          </a:p>
-          <a:p>
-            <a:pPr lvl="1">
-              <a:lnSpc>
-                <a:spcPct val="100000"/>
-              </a:lnSpc>
-            </a:pPr>
-            <a:r>
-              <a:rPr lang="it-IT" dirty="0"/>
-              <a:t>Contenuti trattati nel lavoro di tesi</a:t>
-            </a:r>
-          </a:p>
-          <a:p>
-            <a:pPr lvl="1">
-              <a:lnSpc>
-                <a:spcPct val="100000"/>
-              </a:lnSpc>
+              <a:buNone/>
             </a:pPr>
             <a:endParaRPr lang="it-IT" dirty="0"/>
           </a:p>
@@ -10286,23 +10292,111 @@
               </a:lnSpc>
             </a:pPr>
             <a:r>
-              <a:rPr lang="it-IT" dirty="0"/>
-              <a:t>Evitare di inserire "troppo" testo</a:t>
-            </a:r>
-          </a:p>
-          <a:p>
-            <a:pPr lvl="1">
+              <a:rPr lang="it-IT" sz="2400" b="1" dirty="0"/>
+              <a:t>Obiettivo</a:t>
+            </a:r>
+            <a:r>
+              <a:rPr lang="it-IT" sz="2400" dirty="0"/>
+              <a:t>: Sistema automatico di rilevamento risse ottimizzato per </a:t>
+            </a:r>
+            <a:r>
+              <a:rPr lang="it-IT" sz="2400" i="1" dirty="0"/>
+              <a:t>Edge devices</a:t>
+            </a:r>
+          </a:p>
+          <a:p>
+            <a:pPr>
               <a:lnSpc>
                 <a:spcPct val="100000"/>
               </a:lnSpc>
             </a:pPr>
-            <a:r>
-              <a:rPr lang="it-IT" dirty="0"/>
-              <a:t>Preferire (se appropriati e significativi per il lavoro svolto) diagrammi e figure</a:t>
+            <a:endParaRPr lang="it-IT" sz="2400" dirty="0"/>
+          </a:p>
+          <a:p>
+            <a:pPr>
+              <a:lnSpc>
+                <a:spcPct val="100000"/>
+              </a:lnSpc>
+            </a:pPr>
+            <a:r>
+              <a:rPr lang="it-IT" sz="2400" b="1" dirty="0"/>
+              <a:t>Dataset</a:t>
+            </a:r>
+            <a:r>
+              <a:rPr lang="it-IT" sz="2400" dirty="0"/>
+              <a:t>: </a:t>
+            </a:r>
+            <a:r>
+              <a:rPr lang="it-IT" sz="2400" i="1" dirty="0"/>
+              <a:t>RWF-2000</a:t>
+            </a:r>
+            <a:r>
+              <a:rPr lang="it-IT" sz="2400" dirty="0"/>
+              <a:t> + </a:t>
+            </a:r>
+            <a:r>
+              <a:rPr lang="it-IT" sz="2400" i="1" dirty="0"/>
+              <a:t>Real Life </a:t>
+            </a:r>
+            <a:r>
+              <a:rPr lang="it-IT" sz="2400" i="1" dirty="0" err="1"/>
+              <a:t>Violence</a:t>
+            </a:r>
+            <a:r>
+              <a:rPr lang="it-IT" sz="2400" i="1" dirty="0"/>
+              <a:t> Situations </a:t>
+            </a:r>
+            <a:r>
+              <a:rPr lang="it-IT" sz="2400" dirty="0"/>
+              <a:t>(training/val), </a:t>
+            </a:r>
+            <a:r>
+              <a:rPr lang="it-IT" sz="2400" i="1" dirty="0"/>
+              <a:t>UCF-Crime</a:t>
+            </a:r>
+            <a:r>
+              <a:rPr lang="it-IT" sz="2400" dirty="0"/>
+              <a:t> (test) </a:t>
             </a:r>
           </a:p>
         </p:txBody>
       </p:sp>
+      <p:pic>
+        <p:nvPicPr>
+          <p:cNvPr id="11" name="Immagine 10">
+            <a:extLst>
+              <a:ext uri="{FF2B5EF4-FFF2-40B4-BE49-F238E27FC236}">
+                <a16:creationId xmlns:a16="http://schemas.microsoft.com/office/drawing/2014/main" id="{CE4BF6DE-CFAF-E273-81D1-BC02EB02808E}"/>
+              </a:ext>
+            </a:extLst>
+          </p:cNvPr>
+          <p:cNvPicPr>
+            <a:picLocks noChangeAspect="1"/>
+          </p:cNvPicPr>
+          <p:nvPr/>
+        </p:nvPicPr>
+        <p:blipFill>
+          <a:blip r:embed="rId3">
+            <a:extLst>
+              <a:ext uri="{28A0092B-C50C-407E-A947-70E740481C1C}">
+                <a14:useLocalDpi xmlns:a14="http://schemas.microsoft.com/office/drawing/2010/main" val="0"/>
+              </a:ext>
+            </a:extLst>
+          </a:blip>
+          <a:stretch>
+            <a:fillRect/>
+          </a:stretch>
+        </p:blipFill>
+        <p:spPr>
+          <a:xfrm>
+            <a:off x="6096000" y="365125"/>
+            <a:ext cx="5755459" cy="5478114"/>
+          </a:xfrm>
+          <a:prstGeom prst="rect">
+            <a:avLst/>
+          </a:prstGeom>
+        </p:spPr>
+      </p:pic>
     </p:spTree>
     <p:extLst>
       <p:ext uri="{BB962C8B-B14F-4D97-AF65-F5344CB8AC3E}">
@@ -10377,9 +10471,16 @@
             <p:ph idx="1"/>
           </p:nvPr>
         </p:nvSpPr>
-        <p:spPr/>
+        <p:spPr>
+          <a:xfrm>
+            <a:off x="838200" y="1825625"/>
+            <a:ext cx="5830614" cy="4017614"/>
+          </a:xfrm>
+        </p:spPr>
         <p:txBody>
-          <a:bodyPr/>
+          <a:bodyPr>
+            <a:normAutofit fontScale="85000" lnSpcReduction="20000"/>
+          </a:bodyPr>
           <a:lstStyle/>
           <a:p>
             <a:pPr>
@@ -10388,19 +10489,20 @@
               </a:lnSpc>
             </a:pPr>
             <a:r>
-              <a:rPr lang="it-IT" dirty="0"/>
-              <a:t>Descrivere i risultati principali ottenuti</a:t>
-            </a:r>
-          </a:p>
-          <a:p>
-            <a:pPr>
-              <a:lnSpc>
-                <a:spcPct val="100000"/>
-              </a:lnSpc>
-            </a:pPr>
-            <a:r>
-              <a:rPr lang="it-IT" dirty="0"/>
-              <a:t>Eventuali sviluppi futuri del lavoro svolto</a:t>
+              <a:rPr lang="it-IT" b="1" dirty="0"/>
+              <a:t>Accuratezza</a:t>
+            </a:r>
+            <a:r>
+              <a:rPr lang="it-IT" dirty="0"/>
+              <a:t>: 84% (validazione), 85% (test </a:t>
+            </a:r>
+            <a:r>
+              <a:rPr lang="it-IT" i="1" dirty="0"/>
+              <a:t>UCF-Crime</a:t>
+            </a:r>
+            <a:r>
+              <a:rPr lang="it-IT" dirty="0"/>
+              <a:t>)</a:t>
             </a:r>
           </a:p>
           <a:p>
@@ -10418,19 +10520,12 @@
               </a:lnSpc>
             </a:pPr>
             <a:r>
-              <a:rPr lang="it-IT" dirty="0"/>
-              <a:t> Anche in questo slide evitare di inserire "troppo" testo</a:t>
-            </a:r>
-          </a:p>
-          <a:p>
-            <a:pPr lvl="1">
-              <a:lnSpc>
-                <a:spcPct val="100000"/>
-              </a:lnSpc>
-            </a:pPr>
-            <a:r>
-              <a:rPr lang="it-IT" dirty="0"/>
-              <a:t>Preferire (se appropriati e significativi per il lavoro svolto) diagrammi e figure</a:t>
+              <a:rPr lang="it-IT" b="1" dirty="0"/>
+              <a:t>Filtro spettatori</a:t>
+            </a:r>
+            <a:r>
+              <a:rPr lang="it-IT" dirty="0"/>
+              <a:t>: FP 1306 → 434</a:t>
             </a:r>
           </a:p>
           <a:p>
@@ -10441,8 +10536,130 @@
             </a:pPr>
             <a:endParaRPr lang="it-IT" dirty="0"/>
           </a:p>
+          <a:p>
+            <a:pPr>
+              <a:lnSpc>
+                <a:spcPct val="100000"/>
+              </a:lnSpc>
+            </a:pPr>
+            <a:r>
+              <a:rPr lang="it-IT" b="1" dirty="0"/>
+              <a:t>Modello</a:t>
+            </a:r>
+            <a:r>
+              <a:rPr lang="it-IT" dirty="0"/>
+              <a:t>: 154k parametri, 56.8 </a:t>
+            </a:r>
+            <a:r>
+              <a:rPr lang="it-IT" i="1" dirty="0"/>
+              <a:t>FPS</a:t>
+            </a:r>
+          </a:p>
+          <a:p>
+            <a:pPr>
+              <a:lnSpc>
+                <a:spcPct val="100000"/>
+              </a:lnSpc>
+            </a:pPr>
+            <a:endParaRPr lang="it-IT" dirty="0"/>
+          </a:p>
+          <a:p>
+            <a:pPr>
+              <a:lnSpc>
+                <a:spcPct val="100000"/>
+              </a:lnSpc>
+            </a:pPr>
+            <a:r>
+              <a:rPr lang="it-IT" b="1" dirty="0"/>
+              <a:t>Sviluppo futuro</a:t>
+            </a:r>
+            <a:r>
+              <a:rPr lang="it-IT" dirty="0"/>
+              <a:t>: </a:t>
+            </a:r>
+            <a:r>
+              <a:rPr lang="it-IT" i="1" dirty="0"/>
+              <a:t>GCN</a:t>
+            </a:r>
+            <a:r>
+              <a:rPr lang="it-IT" dirty="0"/>
+              <a:t> multi-persona</a:t>
+            </a:r>
+          </a:p>
         </p:txBody>
       </p:sp>
+      <p:pic>
+        <p:nvPicPr>
+          <p:cNvPr id="7" name="Immagine 6">
+            <a:extLst>
+              <a:ext uri="{FF2B5EF4-FFF2-40B4-BE49-F238E27FC236}">
+                <a16:creationId xmlns:a16="http://schemas.microsoft.com/office/drawing/2014/main" id="{E01F441F-C913-038D-7660-3BAA2691AF04}"/>
+              </a:ext>
+            </a:extLst>
+          </p:cNvPr>
+          <p:cNvPicPr>
+            <a:picLocks noChangeAspect="1"/>
+          </p:cNvPicPr>
+          <p:nvPr/>
+        </p:nvPicPr>
+        <p:blipFill>
+          <a:blip r:embed="rId3">
+            <a:extLst>
+              <a:ext uri="{28A0092B-C50C-407E-A947-70E740481C1C}">
+                <a14:useLocalDpi xmlns:a14="http://schemas.microsoft.com/office/drawing/2010/main" val="0"/>
+              </a:ext>
+            </a:extLst>
+          </a:blip>
+          <a:stretch>
+            <a:fillRect/>
+          </a:stretch>
+        </p:blipFill>
+        <p:spPr>
+          <a:xfrm>
+            <a:off x="6822785" y="479247"/>
+            <a:ext cx="4969820" cy="2692756"/>
+          </a:xfrm>
+          <a:prstGeom prst="rect">
+            <a:avLst/>
+          </a:prstGeom>
+        </p:spPr>
+      </p:pic>
+      <p:pic>
+        <p:nvPicPr>
+          <p:cNvPr id="9" name="Immagine 8">
+            <a:extLst>
+              <a:ext uri="{FF2B5EF4-FFF2-40B4-BE49-F238E27FC236}">
+                <a16:creationId xmlns:a16="http://schemas.microsoft.com/office/drawing/2014/main" id="{293EBDEB-A0AD-64B3-D324-BA34342FB18D}"/>
+              </a:ext>
+            </a:extLst>
+          </p:cNvPr>
+          <p:cNvPicPr>
+            <a:picLocks noChangeAspect="1"/>
+          </p:cNvPicPr>
+          <p:nvPr/>
+        </p:nvPicPr>
+        <p:blipFill>
+          <a:blip r:embed="rId4">
+            <a:extLst>
+              <a:ext uri="{28A0092B-C50C-407E-A947-70E740481C1C}">
+                <a14:useLocalDpi xmlns:a14="http://schemas.microsoft.com/office/drawing/2010/main" val="0"/>
+              </a:ext>
+            </a:extLst>
+          </a:blip>
+          <a:stretch>
+            <a:fillRect/>
+          </a:stretch>
+        </p:blipFill>
+        <p:spPr>
+          <a:xfrm>
+            <a:off x="6822786" y="3286125"/>
+            <a:ext cx="4969819" cy="2698640"/>
+          </a:xfrm>
+          <a:prstGeom prst="rect">
+            <a:avLst/>
+          </a:prstGeom>
+        </p:spPr>
+      </p:pic>
     </p:spTree>
     <p:extLst>
       <p:ext uri="{BB962C8B-B14F-4D97-AF65-F5344CB8AC3E}">
@@ -11637,6 +11854,21 @@
 </file>
 
 <file path=customXml/item1.xml><?xml version="1.0" encoding="utf-8"?>
+<?mso-contentType ?>
+<FormTemplates xmlns="http://schemas.microsoft.com/sharepoint/v3/contenttype/forms">
+  <Display>DocumentLibraryForm</Display>
+  <Edit>DocumentLibraryForm</Edit>
+  <New>DocumentLibraryForm</New>
+</FormTemplates>
+</file>
+
+<file path=customXml/item2.xml><?xml version="1.0" encoding="utf-8"?>
+<p:properties xmlns:p="http://schemas.microsoft.com/office/2006/metadata/properties" xmlns:xsi="http://www.w3.org/2001/XMLSchema-instance" xmlns:pc="http://schemas.microsoft.com/office/infopath/2007/PartnerControls">
+  <documentManagement/>
+</p:properties>
+</file>
+
+<file path=customXml/item3.xml><?xml version="1.0" encoding="utf-8"?>
 <ct:contentTypeSchema xmlns:ct="http://schemas.microsoft.com/office/2006/metadata/contentType" xmlns:ma="http://schemas.microsoft.com/office/2006/metadata/properties/metaAttributes" ct:_="" ma:_="" ma:contentTypeName="Document" ma:contentTypeID="0x0101003E9CE079615D884A940FCB6663749814" ma:contentTypeVersion="12" ma:contentTypeDescription="Create a new document." ma:contentTypeScope="" ma:versionID="730a3498471033da2349798728f12144">
   <xsd:schema xmlns:xsd="http://www.w3.org/2001/XMLSchema" xmlns:xs="http://www.w3.org/2001/XMLSchema" xmlns:p="http://schemas.microsoft.com/office/2006/metadata/properties" xmlns:ns3="c224ffea-49cd-4700-9eee-e6fd160cd816" xmlns:ns4="d543374b-509c-4350-a5c8-3c1bd8055ec5" targetNamespace="http://schemas.microsoft.com/office/2006/metadata/properties" ma:root="true" ma:fieldsID="8e3cb5a327f01176a942c93285e0e7f8" ns3:_="" ns4:_="">
     <xsd:import namespace="c224ffea-49cd-4700-9eee-e6fd160cd816"/>
@@ -11853,22 +12085,32 @@
 </ct:contentTypeSchema>
 </file>
 
-<file path=customXml/item2.xml><?xml version="1.0" encoding="utf-8"?>
-<?mso-contentType ?>
-<FormTemplates xmlns="http://schemas.microsoft.com/sharepoint/v3/contenttype/forms">
-  <Display>DocumentLibraryForm</Display>
-  <Edit>DocumentLibraryForm</Edit>
-  <New>DocumentLibraryForm</New>
-</FormTemplates>
+<file path=customXml/itemProps1.xml><?xml version="1.0" encoding="utf-8"?>
+<ds:datastoreItem xmlns:ds="http://schemas.openxmlformats.org/officeDocument/2006/customXml" ds:itemID="{356A7A6B-3949-4E1B-BAB3-FDC63B06C8ED}">
+  <ds:schemaRefs>
+    <ds:schemaRef ds:uri="http://schemas.microsoft.com/sharepoint/v3/contenttype/forms"/>
+  </ds:schemaRefs>
+</ds:datastoreItem>
 </file>
 
-<file path=customXml/item3.xml><?xml version="1.0" encoding="utf-8"?>
-<p:properties xmlns:p="http://schemas.microsoft.com/office/2006/metadata/properties" xmlns:xsi="http://www.w3.org/2001/XMLSchema-instance" xmlns:pc="http://schemas.microsoft.com/office/infopath/2007/PartnerControls">
-  <documentManagement/>
-</p:properties>
+<file path=customXml/itemProps2.xml><?xml version="1.0" encoding="utf-8"?>
+<ds:datastoreItem xmlns:ds="http://schemas.openxmlformats.org/officeDocument/2006/customXml" ds:itemID="{F10E3395-82EA-4C3E-97EF-88C74BF5F12D}">
+  <ds:schemaRefs>
+    <ds:schemaRef ds:uri="http://purl.org/dc/dcmitype/"/>
+    <ds:schemaRef ds:uri="http://schemas.microsoft.com/office/2006/metadata/properties"/>
+    <ds:schemaRef ds:uri="http://schemas.microsoft.com/office/2006/documentManagement/types"/>
+    <ds:schemaRef ds:uri="http://purl.org/dc/terms/"/>
+    <ds:schemaRef ds:uri="http://purl.org/dc/elements/1.1/"/>
+    <ds:schemaRef ds:uri="http://schemas.microsoft.com/office/infopath/2007/PartnerControls"/>
+    <ds:schemaRef ds:uri="d543374b-509c-4350-a5c8-3c1bd8055ec5"/>
+    <ds:schemaRef ds:uri="http://schemas.openxmlformats.org/package/2006/metadata/core-properties"/>
+    <ds:schemaRef ds:uri="c224ffea-49cd-4700-9eee-e6fd160cd816"/>
+    <ds:schemaRef ds:uri="http://www.w3.org/XML/1998/namespace"/>
+  </ds:schemaRefs>
+</ds:datastoreItem>
 </file>
 
-<file path=customXml/itemProps1.xml><?xml version="1.0" encoding="utf-8"?>
+<file path=customXml/itemProps3.xml><?xml version="1.0" encoding="utf-8"?>
 <ds:datastoreItem xmlns:ds="http://schemas.openxmlformats.org/officeDocument/2006/customXml" ds:itemID="{4694CC2E-81AE-412E-A18E-BB25285B17C3}">
   <ds:schemaRefs>
     <ds:schemaRef ds:uri="http://schemas.microsoft.com/office/2006/metadata/contentType"/>
@@ -11885,29 +12127,4 @@
     <ds:schemaRef ds:uri="http://schemas.microsoft.com/internal/obd"/>
   </ds:schemaRefs>
 </ds:datastoreItem>
-</file>
-
-<file path=customXml/itemProps2.xml><?xml version="1.0" encoding="utf-8"?>
-<ds:datastoreItem xmlns:ds="http://schemas.openxmlformats.org/officeDocument/2006/customXml" ds:itemID="{356A7A6B-3949-4E1B-BAB3-FDC63B06C8ED}">
-  <ds:schemaRefs>
-    <ds:schemaRef ds:uri="http://schemas.microsoft.com/sharepoint/v3/contenttype/forms"/>
-  </ds:schemaRefs>
-</ds:datastoreItem>
-</file>
-
-<file path=customXml/itemProps3.xml><?xml version="1.0" encoding="utf-8"?>
-<ds:datastoreItem xmlns:ds="http://schemas.openxmlformats.org/officeDocument/2006/customXml" ds:itemID="{F10E3395-82EA-4C3E-97EF-88C74BF5F12D}">
-  <ds:schemaRefs>
-    <ds:schemaRef ds:uri="http://purl.org/dc/dcmitype/"/>
-    <ds:schemaRef ds:uri="http://schemas.microsoft.com/office/2006/metadata/properties"/>
-    <ds:schemaRef ds:uri="http://schemas.microsoft.com/office/2006/documentManagement/types"/>
-    <ds:schemaRef ds:uri="http://purl.org/dc/terms/"/>
-    <ds:schemaRef ds:uri="http://purl.org/dc/elements/1.1/"/>
-    <ds:schemaRef ds:uri="http://schemas.microsoft.com/office/infopath/2007/PartnerControls"/>
-    <ds:schemaRef ds:uri="d543374b-509c-4350-a5c8-3c1bd8055ec5"/>
-    <ds:schemaRef ds:uri="http://schemas.openxmlformats.org/package/2006/metadata/core-properties"/>
-    <ds:schemaRef ds:uri="c224ffea-49cd-4700-9eee-e6fd160cd816"/>
-    <ds:schemaRef ds:uri="http://www.w3.org/XML/1998/namespace"/>
-  </ds:schemaRefs>
-</ds:datastoreItem>
 </file>
</xml_diff>